<commit_message>
Pôster e apresentação alinhados ao TCC revisado (burnout, anonimato, CERPRO)
- Pôster: acrescenta burnout (CID-11) e referências reais (Souza et al.
  2010; Treml et al. 2025); estudo de caso anonimizado; cabeçalho passa
  a citar 'Supervisão' e 'Apoio: CERPRO'
- Apresentação: burnout e Souza et al. na fundamentação; anonimato
  explícito na metodologia e nos resultados; capa e encerramento citam
  supervisão e agradecem à CERPRO

Co-Authored-By: Claude Opus 4.8 <noreply@anthropic.com>
Claude-Session: https://claude.ai/code/session_01YQtXhiTtR6MbQyro1e4EQp
</commit_message>
<xml_diff>
--- a/docs/tcc/apresentacao/Apresentacao_Banca_Psike.pptx
+++ b/docs/tcc/apresentacao/Apresentacao_Banca_Psike.pptx
@@ -794,7 +794,7 @@
           <a:lstStyle/>
           <a:p>
             <a:r>
-              <a:t>Agradecer à banca e ao orientador. Sinalizar disponibilidade para a arguição. Ter o app aberto para eventual demonstração ao vivo.</a:t>
+              <a:t>Agradecer à banca, à supervisão da monografia e à CERPRO. Sinalizar disponibilidade para a arguição. Ter o app aberto para eventual demonstração ao vivo.</a:t>
             </a:r>
           </a:p>
         </p:txBody>
@@ -1074,7 +1074,7 @@
           <a:lstStyle/>
           <a:p>
             <a:r>
-              <a:t>Mostrar que a seleção das dimensões tem lastro teórico e alinhamento com a ISO 45003 e o Guia do MTE. Reforçar: avalia a organização.</a:t>
+              <a:t>Mostrar que a seleção das dimensões tem lastro teórico e alinhamento com a ISO 45003 e o Guia do MTE. Reforçar: avalia a organização, não o indivíduo. Citar o burnout (CID-11) como o desfecho que a gestão psicossocial ajuda a prevenir — é um ponto cobrado na avaliação.</a:t>
             </a:r>
           </a:p>
         </p:txBody>
@@ -4613,7 +4613,7 @@
                 </a:solidFill>
                 <a:latin typeface="Calibri"/>
               </a:rPr>
-              <a:t>Orientador(a): [PREENCHER]   ·   Especialização em Engenharia de Segurança do Trabalho — PECE/EPUSP</a:t>
+              <a:t>Supervisão: [PREENCHER]   ·   Especialização em Engenharia de Segurança do Trabalho — PECE/EPUSP</a:t>
             </a:r>
           </a:p>
           <a:p>
@@ -4825,7 +4825,7 @@
                 </a:solidFill>
                 <a:latin typeface="Calibri"/>
               </a:rPr>
-              <a:t>•  [PREENCHER: nº de respondentes, taxa de adesão e nota média / faixa de risco por dimensão — inserir tabela e gráfico do painel real].</a:t>
+              <a:t>•  [PREENCHER: nº de respondentes, taxa de adesão e nota média / faixa de risco por dimensão — inserir tabela e gráfico agregado, sem identificar a organização].</a:t>
             </a:r>
           </a:p>
           <a:p>
@@ -5412,17 +5412,33 @@
           <a:p>
             <a:pPr algn="l">
               <a:spcAft>
+                <a:spcPts val="1000"/>
+              </a:spcAft>
+            </a:pPr>
+            <a:r>
+              <a:rPr sz="1500" b="0">
+                <a:solidFill>
+                  <a:srgbClr val="C7CEDB"/>
+                </a:solidFill>
+                <a:latin typeface="Calibri"/>
+              </a:rPr>
+              <a:t>Psike — plataforma de gestão de riscos psicossociais (NR-1)</a:t>
+            </a:r>
+          </a:p>
+          <a:p>
+            <a:pPr algn="l">
+              <a:spcAft>
                 <a:spcPts val="800"/>
               </a:spcAft>
             </a:pPr>
             <a:r>
-              <a:rPr sz="1500" b="0">
-                <a:solidFill>
-                  <a:srgbClr val="C7CEDB"/>
+              <a:rPr sz="1300" b="0">
+                <a:solidFill>
+                  <a:srgbClr val="AEB8C9"/>
                 </a:solidFill>
                 <a:latin typeface="Calibri"/>
               </a:rPr>
-              <a:t>Psike — plataforma de gestão de riscos psicossociais (NR-1)</a:t>
+              <a:t>Agradecimento: CERPRO</a:t>
             </a:r>
           </a:p>
         </p:txBody>
@@ -6264,7 +6280,7 @@
               </a:spcAft>
             </a:pPr>
             <a:r>
-              <a:rPr sz="1800" b="0">
+              <a:rPr sz="1700" b="0">
                 <a:solidFill>
                   <a:srgbClr val="16233F"/>
                 </a:solidFill>
@@ -6280,13 +6296,13 @@
               </a:spcAft>
             </a:pPr>
             <a:r>
-              <a:rPr sz="1800" b="0">
+              <a:rPr sz="1700" b="0">
                 <a:solidFill>
                   <a:srgbClr val="16233F"/>
                 </a:solidFill>
                 <a:latin typeface="Calibri"/>
               </a:rPr>
-              <a:t>•  Modelos de base: demanda-controle (Karasek), esforço-recompensa (Siegrist), multidimensional (COPSOQ).</a:t>
+              <a:t>•  Modelos de base: demanda-controle-apoio (Karasek; Johnson &amp; Hall), esforço-recompensa (Siegrist), multidimensional (COPSOQ).</a:t>
             </a:r>
           </a:p>
           <a:p>
@@ -6296,12 +6312,28 @@
               </a:spcAft>
             </a:pPr>
             <a:r>
-              <a:rPr sz="1800" b="0">
+              <a:rPr sz="1700" b="0">
                 <a:solidFill>
                   <a:srgbClr val="16233F"/>
                 </a:solidFill>
                 <a:latin typeface="Calibri"/>
               </a:rPr>
+              <a:t>•  Burnout como desfecho: reconhecido na CID-11 (QD85), doença ocupacional adotada no Brasil desde 2025; afastamentos em alta (Treml et al., 2025).</a:t>
+            </a:r>
+          </a:p>
+          <a:p>
+            <a:pPr algn="l">
+              <a:spcAft>
+                <a:spcPts val="1000"/>
+              </a:spcAft>
+            </a:pPr>
+            <a:r>
+              <a:rPr sz="1700" b="0">
+                <a:solidFill>
+                  <a:srgbClr val="16233F"/>
+                </a:solidFill>
+                <a:latin typeface="Calibri"/>
+              </a:rPr>
               <a:t>•  ISO 45003:2021: primeira norma internacional de riscos psicossociais; recomenda integrar ao sistema de gestão de SST existente.</a:t>
             </a:r>
           </a:p>
@@ -6312,7 +6344,23 @@
               </a:spcAft>
             </a:pPr>
             <a:r>
-              <a:rPr sz="1800" b="0">
+              <a:rPr sz="1700" b="0">
+                <a:solidFill>
+                  <a:srgbClr val="16233F"/>
+                </a:solidFill>
+                <a:latin typeface="Calibri"/>
+              </a:rPr>
+              <a:t>•  Setor elétrico: maior prevalência de transtornos mentais comuns com alta demanda, baixo controle e baixo apoio (Souza et al., 2010).</a:t>
+            </a:r>
+          </a:p>
+          <a:p>
+            <a:pPr algn="l">
+              <a:spcAft>
+                <a:spcPts val="1000"/>
+              </a:spcAft>
+            </a:pPr>
+            <a:r>
+              <a:rPr sz="1700" b="0">
                 <a:solidFill>
                   <a:srgbClr val="16233F"/>
                 </a:solidFill>
@@ -6498,7 +6546,7 @@
                 </a:solidFill>
                 <a:latin typeface="Calibri"/>
               </a:rPr>
-              <a:t>•  Três decisões de arquitetura: custo zero · sem instalação · anonimato por construção (LGPD).</a:t>
+              <a:t>•  Três decisões de arquitetura: custo zero · sem instalação · anonimato por construção (LGPD) — sem nome, sem dados que identifiquem pessoas ou a organização estudada.</a:t>
             </a:r>
           </a:p>
           <a:p>

</xml_diff>

<commit_message>
Pivota o TCC para investigação de acidentes pela árvore de causas
Novo tema a pedido do autor (prazo set/2026), mantendo as exigências da
supervisão: 40-80 folhas, revisão com refs recentes, burnout citado
(como fator humano contribuinte), passo a passo, resultados+discussão
integrados, conclusão curta e anonimato total (agradecimento à CERPRO).

- Novo gerador gerar_tcc_acidentes.py e TCC_Acidentes_ArvoreCausas_MODELO.docx:
  árvore de causas (Binder/Monteau/Almeida), modelos causais (Heinrich,
  Bird, Reason, Hollnagel), NBR 14280, quase acidentes, estatísticas
  Abracopel/Abradee 2024, estudo de caso documental + piloto de campo
- Pôster e apresentação (13 slides) reescritos para o novo tema
- Mantém o TCC psicossocial anterior no repositório como alternativa
</commit_message>
<xml_diff>
--- a/docs/tcc/apresentacao/Apresentacao_Banca_Psike.pptx
+++ b/docs/tcc/apresentacao/Apresentacao_Banca_Psike.pptx
@@ -514,7 +514,7 @@
           <a:lstStyle/>
           <a:p>
             <a:r>
-              <a:t>Cumprimentar a banca. Apresentar-se, o tema e o orientador. Frase de abertura: o TCC nasce de uma exigência nova da NR-1 (2024) e entrega uma solução prática, aplicada no setor de distribuição de energia. Duração-alvo da defesa: ~15 min + arguição.</a:t>
+              <a:t>Cumprimentar a banca. Frase de abertura: no setor elétrico o acidente raramente é leve — e a NR-1 obriga a analisar cada ocorrência e realimentar o PGR. Este TCC entrega o instrumento que torna isso exequível. Duração-alvo: ~15 min + arguição.</a:t>
             </a:r>
           </a:p>
         </p:txBody>
@@ -584,7 +584,7 @@
           <a:lstStyle/>
           <a:p>
             <a:r>
-              <a:t>Aqui entram os dados reais do piloto. NÃO inventar. Se o piloto ainda não ocorreu na data da defesa, apresentar como resultado esperado e mostrar o texto do IRO gerado com dados de demonstração.</a:t>
+              <a:t>Dados reais aqui — NÃO inventar. Se o piloto estiver em curso na defesa, apresentar a parte documental como resultado principal e o piloto como em andamento.</a:t>
             </a:r>
           </a:p>
         </p:txBody>
@@ -654,7 +654,7 @@
           <a:lstStyle/>
           <a:p>
             <a:r>
-              <a:t>Mostrar maturidade reconhecendo limites — a banca valoriza. Enquadrar o instrumento como triagem (screening), não diagnóstico.</a:t>
+              <a:t>Reconhecer limites com maturidade — a banca valoriza. O roteiro de 3 níveis é operacionalização, não o diagrama completo do método.</a:t>
             </a:r>
           </a:p>
         </p:txBody>
@@ -724,7 +724,7 @@
           <a:lstStyle/>
           <a:p>
             <a:r>
-              <a:t>Fechar reafirmando a contribuição prática e a visão de plataforma. Deixar gancho para os trabalhos futuros — mostra que o projeto tem continuidade.</a:t>
+              <a:t>Fechar reafirmando: método consolidado + ferramenta acessível = prevenção que aprende com cada evento. Gancho de continuidade.</a:t>
             </a:r>
           </a:p>
         </p:txBody>
@@ -794,7 +794,7 @@
           <a:lstStyle/>
           <a:p>
             <a:r>
-              <a:t>Agradecer à banca, à supervisão da monografia e à CERPRO. Sinalizar disponibilidade para a arguição. Ter o app aberto para eventual demonstração ao vivo.</a:t>
+              <a:t>Agradecer à banca, à supervisão da monografia e à CERPRO. Ter o app aberto para eventual demonstração ao vivo.</a:t>
             </a:r>
           </a:p>
         </p:txBody>
@@ -864,7 +864,7 @@
           <a:lstStyle/>
           <a:p>
             <a:r>
-              <a:t>Ancorar o problema: a norma mudou, o prazo é real e próximo, e a forma como as empresas cumprem hoje é frágil. Situar o setor de energia como campo pertinente.</a:t>
+              <a:t>Ancorar o problema nos números do setor e na exigência da NR-1. Ponto-chave: investigação rasa = acidente repetido.</a:t>
             </a:r>
           </a:p>
         </p:txBody>
@@ -934,7 +934,7 @@
           <a:lstStyle/>
           <a:p>
             <a:r>
-              <a:t>Deixar claro o 'gap' que justifica o trabalho. Enfatizar custo quase nulo e replicabilidade como diferencial.</a:t>
+              <a:t>Deixar claro o gap: método existe, norma exige, ferramenta acessível não existia. O diferencial é operacionalizar.</a:t>
             </a:r>
           </a:p>
         </p:txBody>
@@ -1004,7 +1004,7 @@
           <a:lstStyle/>
           <a:p>
             <a:r>
-              <a:t>Ler o objetivo geral com calma; passar pelos específicos rapidamente — eles espelham a estrutura da metodologia e dos módulos.</a:t>
+              <a:t>Ler o geral com calma; os específicos espelham a estrutura do trabalho.</a:t>
             </a:r>
           </a:p>
         </p:txBody>
@@ -1074,7 +1074,7 @@
           <a:lstStyle/>
           <a:p>
             <a:r>
-              <a:t>Mostrar que a seleção das dimensões tem lastro teórico e alinhamento com a ISO 45003 e o Guia do MTE. Reforçar: avalia a organização, não o indivíduo. Citar o burnout (CID-11) como o desfecho que a gestão psicossocial ajuda a prevenir — é um ponto cobrado na avaliação.</a:t>
+              <a:t>Mostrar a linha: modelo causal define a investigação. Citar o burnout como fator humano contribuinte (ponto cobrado na avaliação). Fechar com a tradução do método para o software.</a:t>
             </a:r>
           </a:p>
         </p:txBody>
@@ -1144,7 +1144,7 @@
           <a:lstStyle/>
           <a:p>
             <a:r>
-              <a:t>Explicar por que Sheets/Apps Script: gratuito e replicável. Explicar os pontos de corte como julgamento técnico conservador, a calibrar com histórico.</a:t>
+              <a:t>Destacar o desenho em duas partes: o retrospectivo compara profundidade causal; o piloto mede reporte e tempo de registro. Anonimato: sem nomes, datas exatas ou locais.</a:t>
             </a:r>
           </a:p>
         </p:txBody>
@@ -1214,7 +1214,7 @@
           <a:lstStyle/>
           <a:p>
             <a:r>
-              <a:t>Este é o coração da contribuição: a mesma base de dados vira um 'inventário de riscos vivo', alimentado por 4 processos operacionais. Os quatro módulos estão implementados e funcionais.</a:t>
+              <a:t>O módulo de acidentes é o coração do TCC; os demais alimentam a mesma base — dá para cruzar ocorrência × permissão emitida × sinalização psicossocial do setor.</a:t>
             </a:r>
           </a:p>
         </p:txBody>
@@ -1284,7 +1284,7 @@
           <a:lstStyle/>
           <a:p>
             <a:r>
-              <a:t>Demonstrar o fluxo: trabalhador responde no celular (anônimo) → painel classifica por dimensão → app gera o parágrafo do IRO pronto para colar no PGR. Se possível, fazer uma demo ao vivo aqui.</a:t>
+              <a:t>Ponto de venda técnico: o formulário NÃO permite concluir só com causas imediatas — é o método da árvore traduzido em software. Se possível, demo ao vivo aqui.</a:t>
             </a:r>
           </a:p>
         </p:txBody>
@@ -1354,7 +1354,7 @@
           <a:lstStyle/>
           <a:p>
             <a:r>
-              <a:t>Passar rápido: mostrar que a plataforma cobre o campo (APR com assinatura e GPS), a ergonomia (AEP com parecer automático) e a investigação de acidentes com árvore de causas em 3 níveis.</a:t>
+              <a:t>Passar rápido — a mensagem é integração: a mesma base de dados permite cruzar ocorrências com permissões e com a sinalização psicossocial (fatores humanos).</a:t>
             </a:r>
           </a:p>
         </p:txBody>
@@ -4516,8 +4516,8 @@
         </p:nvSpPr>
         <p:spPr>
           <a:xfrm>
-            <a:off x="822960" y="2194560"/>
-            <a:ext cx="10515600" cy="2377440"/>
+            <a:off x="822960" y="2011680"/>
+            <a:ext cx="10515600" cy="2651760"/>
           </a:xfrm>
           <a:prstGeom prst="rect">
             <a:avLst/>
@@ -4536,13 +4536,13 @@
               </a:spcAft>
             </a:pPr>
             <a:r>
-              <a:rPr sz="3400" b="1">
+              <a:rPr sz="3200" b="1">
                 <a:solidFill>
                   <a:srgbClr val="FFFFFF"/>
                 </a:solidFill>
                 <a:latin typeface="Georgia"/>
               </a:rPr>
-              <a:t>GESTÃO DIGITAL DE RISCOS PSICOSSOCIAIS CONFORME A NR-1</a:t>
+              <a:t>INVESTIGAÇÃO DIGITAL DE ACIDENTES PELO MÉTODO DA ÁRVORE DE CAUSAS</a:t>
             </a:r>
           </a:p>
           <a:p>
@@ -4558,7 +4558,7 @@
                 </a:solidFill>
                 <a:latin typeface="Calibri"/>
               </a:rPr>
-              <a:t>Desenvolvimento e aplicação de uma plataforma de SST em serviços de distribuição de energia elétrica</a:t>
+              <a:t>Registro e análise de acidentes e quase acidentes integrados à NR-1 em serviços de distribuição de energia elétrica</a:t>
             </a:r>
           </a:p>
         </p:txBody>
@@ -4754,7 +4754,7 @@
                 </a:solidFill>
                 <a:latin typeface="Georgia"/>
               </a:rPr>
-              <a:t>Plataforma operacional + aplicação piloto</a:t>
+              <a:t>Sistema operacional + estudo de caso</a:t>
             </a:r>
           </a:p>
         </p:txBody>
@@ -4793,7 +4793,7 @@
                 </a:solidFill>
                 <a:latin typeface="Calibri"/>
               </a:rPr>
-              <a:t>•  Plataforma implementada integralmente: 4 módulos operacionais, custo de operação nulo.</a:t>
+              <a:t>•  Sistema implementado integralmente: registro, investigação em 3 níveis, ações e indicadores — sem transcrição manual, custo de operação nulo.</a:t>
             </a:r>
           </a:p>
           <a:p>
@@ -4809,7 +4809,7 @@
                 </a:solidFill>
                 <a:latin typeface="Calibri"/>
               </a:rPr>
-              <a:t>•  Fluxo do Módulo 1 sem qualquer etapa manual de tabulação.</a:t>
+              <a:t>•  [PREENCHER: parte documental — distribuição de causas por nível na análise original × estruturada; 2–3 casos anonimizados].</a:t>
             </a:r>
           </a:p>
           <a:p>
@@ -4825,7 +4825,7 @@
                 </a:solidFill>
                 <a:latin typeface="Calibri"/>
               </a:rPr>
-              <a:t>•  [PREENCHER: nº de respondentes, taxa de adesão e nota média / faixa de risco por dimensão — inserir tabela e gráfico agregado, sem identificar a organização].</a:t>
+              <a:t>•  [PREENCHER: piloto — volume por tipo, razão quase acidentes/acidentes, tempo mediano evento–registro, ações no prazo; inserir gráficos].</a:t>
             </a:r>
           </a:p>
           <a:p>
@@ -4841,7 +4841,7 @@
                 </a:solidFill>
                 <a:latin typeface="Calibri"/>
               </a:rPr>
-              <a:t>•  [PREENCHER: transcrever o texto do IRO gerado pela plataforma no piloto, como evidência do produto final].</a:t>
+              <a:t>•  [PREENCHER: revisões do IRO/plano de ação decorrentes, sem identificar a organização].</a:t>
             </a:r>
           </a:p>
         </p:txBody>
@@ -5005,7 +5005,7 @@
                 </a:solidFill>
                 <a:latin typeface="Calibri"/>
               </a:rPr>
-              <a:t>•  A barreira à conformidade com a NR-1 é operacional, não conceitual: a digitalização reduz o custo do ciclo a quase zero.</a:t>
+              <a:t>•  Se a investigação estruturada revelou mais causas básicas: o instrumento condiciona a profundidade — confirma Binder &amp; Almeida (1997).</a:t>
             </a:r>
           </a:p>
           <a:p>
@@ -5021,7 +5021,23 @@
                 </a:solidFill>
                 <a:latin typeface="Calibri"/>
               </a:rPr>
-              <a:t>•  Ganhos alinhados à norma: anonimato, consistência da classificação e rastreabilidade dos registros.</a:t>
+              <a:t>•  Se o reporte de quase acidentes cresceu: a subnotificação era atrito de processo — o sistema captura a base da pirâmide (Heinrich; Bird).</a:t>
+            </a:r>
+          </a:p>
+          <a:p>
+            <a:pPr algn="l">
+              <a:spcAft>
+                <a:spcPts val="1000"/>
+              </a:spcAft>
+            </a:pPr>
+            <a:r>
+              <a:rPr sz="1800" b="0">
+                <a:solidFill>
+                  <a:srgbClr val="16233F"/>
+                </a:solidFill>
+                <a:latin typeface="Calibri"/>
+              </a:rPr>
+              <a:t>•  Fatores humanos entre as causas básicas articulam acidentes e gestão psicossocial da NR-1 — faces do mesmo sistema.</a:t>
             </a:r>
           </a:p>
           <a:p>
@@ -5037,7 +5053,7 @@
                 </a:solidFill>
                 <a:latin typeface="Calibri"/>
               </a:rPr>
-              <a:t>–  Limitações: instrumento de triagem (10 itens), sem validação psicométrica formal;</a:t>
+              <a:t>–  Limitações: roteiro em 3 níveis é simplificação da árvore completa;</a:t>
             </a:r>
           </a:p>
           <a:p>
@@ -5053,7 +5069,7 @@
                 </a:solidFill>
                 <a:latin typeface="Calibri"/>
               </a:rPr>
-              <a:t>–  pontos de corte por julgamento técnico, a calibrar com histórico;</a:t>
+              <a:t>–  qualidade dos registros históricos; piloto curto em uma organização;</a:t>
             </a:r>
           </a:p>
           <a:p>
@@ -5069,23 +5085,7 @@
                 </a:solidFill>
                 <a:latin typeface="Calibri"/>
               </a:rPr>
-              <a:t>–  sem autenticação e sem segregação por empresa (uso comercial exige);</a:t>
-            </a:r>
-          </a:p>
-          <a:p>
-            <a:pPr algn="l" lvl="1">
-              <a:spcAft>
-                <a:spcPts val="1000"/>
-              </a:spcAft>
-            </a:pPr>
-            <a:r>
-              <a:rPr sz="1600" b="0">
-                <a:solidFill>
-                  <a:srgbClr val="5B6576"/>
-                </a:solidFill>
-                <a:latin typeface="Calibri"/>
-              </a:rPr>
-              <a:t>–  limites da camada gratuita do Sheets; amostra restrita a uma organização.</a:t>
+              <a:t>–  sem autenticação/segregação por empresa; limites da camada gratuita.</a:t>
             </a:r>
           </a:p>
         </p:txBody>
@@ -5249,7 +5249,7 @@
                 </a:solidFill>
                 <a:latin typeface="Calibri"/>
               </a:rPr>
-              <a:t>•  A digitalização viabiliza o cumprimento da NR-1 mesmo com equipes de SST enxutas, a custo praticamente nulo.</a:t>
+              <a:t>•  A digitalização do ciclo registro–investigação–ação torna exequível a exigência da NR-1 de analisar ocorrências e realimentar o PGR — a custo praticamente nulo.</a:t>
             </a:r>
           </a:p>
           <a:p>
@@ -5265,7 +5265,7 @@
                 </a:solidFill>
                 <a:latin typeface="Calibri"/>
               </a:rPr>
-              <a:t>•  Conceito central: inventário de riscos 'vivo', alimentado pelos próprios processos operacionais de SST.</a:t>
+              <a:t>•  Deslocamento essencial: da culpabilização individual para os fatores organizacionais — com rastreabilidade de auditoria.</a:t>
             </a:r>
           </a:p>
           <a:p>
@@ -5281,7 +5281,7 @@
                 </a:solidFill>
                 <a:latin typeface="Calibri"/>
               </a:rPr>
-              <a:t>•  Trabalhos futuros: validação psicométrica; calibração dos cortes; autenticação e segregação por empresa; migração para banco de dados; acompanhamento longitudinal da eficácia das medidas.</a:t>
+              <a:t>•  Trabalhos futuros: diagrama completo da árvore no software; autenticação e segregação por organização; leitura longitudinal dos indicadores; cruzamento ocorrências × permissões × psicossocial.</a:t>
             </a:r>
           </a:p>
         </p:txBody>
@@ -5422,7 +5422,7 @@
                 </a:solidFill>
                 <a:latin typeface="Calibri"/>
               </a:rPr>
-              <a:t>Psike — plataforma de gestão de riscos psicossociais (NR-1)</a:t>
+              <a:t>Psike — investigação digital de acidentes pela árvore de causas (NR-1)</a:t>
             </a:r>
           </a:p>
           <a:p>
@@ -5563,7 +5563,7 @@
                 </a:solidFill>
                 <a:latin typeface="Georgia"/>
               </a:rPr>
-              <a:t>Uma exigência nova, um processo ainda manual</a:t>
+              <a:t>A norma exige analisar; a prática ainda é manual</a:t>
             </a:r>
           </a:p>
         </p:txBody>
@@ -5602,7 +5602,7 @@
                 </a:solidFill>
                 <a:latin typeface="Calibri"/>
               </a:rPr>
-              <a:t>•  A Portaria MTE nº 1.419/2024 atualizou a NR-1: fatores de risco psicossocial passaram a ser obrigatórios no GRO/PGR.</a:t>
+              <a:t>•  A NR-1 (GRO) obriga o empregador a analisar acidentes e doenças relacionadas ao trabalho, identificar causas e realimentar o PGR.</a:t>
             </a:r>
           </a:p>
           <a:p>
@@ -5618,7 +5618,7 @@
                 </a:solidFill>
                 <a:latin typeface="Calibri"/>
               </a:rPr>
-              <a:t>•  Exigibilidade a partir de 26/05/2026 — alcança todo empregador CLT.</a:t>
+              <a:t>•  Na prática: registro em papel, horas/dias após o evento; investigação que para no “ato inseguro”; quase acidentes raramente reportados; ações sem acompanhamento.</a:t>
             </a:r>
           </a:p>
           <a:p>
@@ -5634,23 +5634,23 @@
                 </a:solidFill>
                 <a:latin typeface="Calibri"/>
               </a:rPr>
-              <a:t>•  Não basta aplicar um questionário: é preciso identificar, avaliar, classificar, registrar no Inventário de Riscos (IRO) e agir — com rastreabilidade de longo prazo.</a:t>
-            </a:r>
-          </a:p>
-          <a:p>
-            <a:pPr algn="l">
+              <a:t>•  A literatura chama essa prática de paradigma culpabilizador — e a associa diretamente à recorrência dos eventos (Binder; Almeida, 1997; Almeida, 2006).</a:t>
+            </a:r>
+          </a:p>
+          <a:p>
+            <a:pPr algn="l" lvl="1">
               <a:spcAft>
                 <a:spcPts val="1000"/>
               </a:spcAft>
             </a:pPr>
             <a:r>
-              <a:rPr sz="1800" b="0">
-                <a:solidFill>
-                  <a:srgbClr val="16233F"/>
+              <a:rPr sz="1600" b="0">
+                <a:solidFill>
+                  <a:srgbClr val="5B6576"/>
                 </a:solidFill>
                 <a:latin typeface="Calibri"/>
               </a:rPr>
-              <a:t>•  Na prática, a maioria das empresas faz isso em papel/planilha: baixa rastreabilidade e alto custo operacional.</a:t>
+              <a:t>–  Setor elétrico: 2.089 acidentes de origem elétrica em 2023, 781 óbitos (Abracopel, 2024); 250 mortes na rede de distribuição (Abradee, 2024).</a:t>
             </a:r>
           </a:p>
           <a:p>
@@ -5666,7 +5666,7 @@
                 </a:solidFill>
                 <a:latin typeface="Calibri"/>
               </a:rPr>
-              <a:t>–  No setor de distribuição de energia, os fatores psicossociais convivem com riscos graves (NR-10, NR-35) e demandas típicas: pressão por restabelecimento, turnos, sobreaviso, risco de acidente fatal.</a:t>
+              <a:t>–  Eventos raros e graves ⇒ o quase acidente é o insumo mais abundante do aprendizado — se for reportado.</a:t>
             </a:r>
           </a:p>
         </p:txBody>
@@ -5791,7 +5791,7 @@
                 </a:solidFill>
                 <a:latin typeface="Georgia"/>
               </a:rPr>
-              <a:t>A lacuna entre a norma e as ferramentas</a:t>
+              <a:t>Três razões para este trabalho</a:t>
             </a:r>
           </a:p>
         </p:txBody>
@@ -5830,7 +5830,7 @@
                 </a:solidFill>
                 <a:latin typeface="Calibri"/>
               </a:rPr>
-              <a:t>•  Soluções comerciais de SST: custo alto para empresas menores.</a:t>
+              <a:t>•  Gravidade setorial: letalidade dos acidentes elétricos supera 1/3 das ocorrências (Abracopel, 2024) — cada evento desperdiçado custa caro.</a:t>
             </a:r>
           </a:p>
           <a:p>
@@ -5846,7 +5846,7 @@
                 </a:solidFill>
                 <a:latin typeface="Calibri"/>
               </a:rPr>
-              <a:t>•  Instrumentos validados extensos (ex.: COPSOQ, 80+ itens): exigem competência estatística pouco disponível em equipes enxutas.</a:t>
+              <a:t>•  Exigência normativa: NR-1 demanda análise com método e registro rastreável; NBR 14280 padroniza cadastro e estatísticas.</a:t>
             </a:r>
           </a:p>
           <a:p>
@@ -5862,7 +5862,7 @@
                 </a:solidFill>
                 <a:latin typeface="Calibri"/>
               </a:rPr>
-              <a:t>•  Formulário impresso tabulado à mão: fragiliza justamente o que a NR-1 passou a exigir — anonimato, consistência e rastreabilidade.</a:t>
+              <a:t>•  Lacuna prática: o método da árvore de causas é consolidado na literatura brasileira desde os anos 1990, mas carece de ferramenta digital acessível que o leve ao campo.</a:t>
             </a:r>
           </a:p>
           <a:p>
@@ -5878,7 +5878,7 @@
                 </a:solidFill>
                 <a:latin typeface="Calibri"/>
               </a:rPr>
-              <a:t>•  Oportunidade: demonstrar uma solução digital de custo praticamente nulo, replicável por profissionais de SST sem apoio de TI.</a:t>
+              <a:t>•  Proposta: sistema de custo praticamente nulo, replicável por equipes de SST enxutas, sem apoio de TI.</a:t>
             </a:r>
           </a:p>
         </p:txBody>
@@ -6042,7 +6042,7 @@
                 </a:solidFill>
                 <a:latin typeface="Calibri"/>
               </a:rPr>
-              <a:t>•  GERAL: desenvolver e aplicar uma plataforma digital para identificação, avaliação e documentação de fatores de risco psicossocial conforme a NR-1, integrada à gestão de riscos de uma distribuidora de energia.</a:t>
+              <a:t>•  GERAL: desenvolver e aplicar um sistema digital de registro e investigação de acidentes e quase acidentes, estruturado no método da árvore de causas e integrado ao GRO (NR-1), em uma organização de distribuição de energia elétrica.</a:t>
             </a:r>
           </a:p>
           <a:p>
@@ -6058,7 +6058,7 @@
                 </a:solidFill>
                 <a:latin typeface="Calibri"/>
               </a:rPr>
-              <a:t>–  Sistematizar os requisitos da NR-1 e referências (Guia MTE, ISO 45003);</a:t>
+              <a:t>–  Sistematizar os requisitos da NR-1, NBR 14280, ISO 45001 e a articulação com a CAT/eSocial;</a:t>
             </a:r>
           </a:p>
           <a:p>
@@ -6074,7 +6074,7 @@
                 </a:solidFill>
                 <a:latin typeface="Calibri"/>
               </a:rPr>
-              <a:t>–  Construir um instrumento enxuto (10 itens, 6 dimensões) com coleta anônima e classificação objetiva de risco;</a:t>
+              <a:t>–  Revisar os modelos de causalidade e o método da árvore de causas;</a:t>
             </a:r>
           </a:p>
           <a:p>
@@ -6090,7 +6090,7 @@
                 </a:solidFill>
                 <a:latin typeface="Calibri"/>
               </a:rPr>
-              <a:t>–  Implementar a plataforma (web + backend gratuito) com painel e geração automática de texto para o IRO;</a:t>
+              <a:t>–  Implementar registro em campo, investigação em 3 níveis de causas, gestão de ações e indicadores;</a:t>
             </a:r>
           </a:p>
           <a:p>
@@ -6106,7 +6106,7 @@
                 </a:solidFill>
                 <a:latin typeface="Calibri"/>
               </a:rPr>
-              <a:t>–  Digitalizar processos complementares: APR (NR-10/35), AEP (NR-17) e acidentes/near-miss;</a:t>
+              <a:t>–  Integrar aos módulos complementares (PT NR-10/35, psicossocial NR-1, AEP NR-17) na mesma base;</a:t>
             </a:r>
           </a:p>
           <a:p>
@@ -6122,7 +6122,7 @@
                 </a:solidFill>
                 <a:latin typeface="Calibri"/>
               </a:rPr>
-              <a:t>–  Aplicar em piloto e discutir resultados, limitações e generalização.</a:t>
+              <a:t>–  Aplicar em estudo de caso (retrospectivo + piloto) e discutir resultados e limitações.</a:t>
             </a:r>
           </a:p>
         </p:txBody>
@@ -6247,7 +6247,7 @@
                 </a:solidFill>
                 <a:latin typeface="Georgia"/>
               </a:rPr>
-              <a:t>Do conceito às seis dimensões avaliadas</a:t>
+              <a:t>Do modelo causal ao roteiro de investigação</a:t>
             </a:r>
           </a:p>
         </p:txBody>
@@ -6286,7 +6286,7 @@
                 </a:solidFill>
                 <a:latin typeface="Calibri"/>
               </a:rPr>
-              <a:t>•  Fatores psicossociais: aspectos da organização e gestão do trabalho com potencial de dano — abordagem organizacional, não diagnóstico individual.</a:t>
+              <a:t>•  Heinrich (1931) e Bird &amp; Germain (1985): a pirâmide de eventos — muitos quase acidentes antecedem a lesão grave; reportá-los é prevenção.</a:t>
             </a:r>
           </a:p>
           <a:p>
@@ -6302,7 +6302,7 @@
                 </a:solidFill>
                 <a:latin typeface="Calibri"/>
               </a:rPr>
-              <a:t>•  Modelos de base: demanda-controle-apoio (Karasek; Johnson &amp; Hall), esforço-recompensa (Siegrist), multidimensional (COPSOQ).</a:t>
+              <a:t>•  Reason (1990; 1997): falhas ativas × condições latentes — investigar só a conduta do trabalhador deixa intactas as causas organizacionais.</a:t>
             </a:r>
           </a:p>
           <a:p>
@@ -6318,7 +6318,7 @@
                 </a:solidFill>
                 <a:latin typeface="Calibri"/>
               </a:rPr>
-              <a:t>•  Burnout como desfecho: reconhecido na CID-11 (QD85), doença ocupacional adotada no Brasil desde 2025; afastamentos em alta (Treml et al., 2025).</a:t>
+              <a:t>•  Árvore de causas (INRS; Binder; Monteau; Almeida): reconstrução da rede de fatos, sem juízo de culpa — referência brasileira consolidada.</a:t>
             </a:r>
           </a:p>
           <a:p>
@@ -6334,7 +6334,7 @@
                 </a:solidFill>
                 <a:latin typeface="Calibri"/>
               </a:rPr>
-              <a:t>•  ISO 45003:2021: primeira norma internacional de riscos psicossociais; recomenda integrar ao sistema de gestão de SST existente.</a:t>
+              <a:t>•  Fatores humanos e organizacionais nas causas básicas: fadiga, pressão de tempo, sobrecarga — ponte com os riscos psicossociais da NR-1 e com o burnout (CID-11/QD85; Treml et al., 2025).</a:t>
             </a:r>
           </a:p>
           <a:p>
@@ -6350,23 +6350,7 @@
                 </a:solidFill>
                 <a:latin typeface="Calibri"/>
               </a:rPr>
-              <a:t>•  Setor elétrico: maior prevalência de transtornos mentais comuns com alta demanda, baixo controle e baixo apoio (Souza et al., 2010).</a:t>
-            </a:r>
-          </a:p>
-          <a:p>
-            <a:pPr algn="l">
-              <a:spcAft>
-                <a:spcPts val="1000"/>
-              </a:spcAft>
-            </a:pPr>
-            <a:r>
-              <a:rPr sz="1700" b="0">
-                <a:solidFill>
-                  <a:srgbClr val="16233F"/>
-                </a:solidFill>
-                <a:latin typeface="Calibri"/>
-              </a:rPr>
-              <a:t>•  Seis dimensões adotadas: carga e ritmo · autonomia e controle · clareza de papel · apoio social e de liderança · reconhecimento · assédio e violência.</a:t>
+              <a:t>•  Operacionalização adotada: 3 níveis obrigatórios — causas imediatas → subjacentes → básicas; o formulário não conclui no nível 1.</a:t>
             </a:r>
           </a:p>
         </p:txBody>
@@ -6491,7 +6475,7 @@
                 </a:solidFill>
                 <a:latin typeface="Georgia"/>
               </a:rPr>
-              <a:t>Arquitetura da plataforma e instrumento</a:t>
+              <a:t>Artefato + estudo de caso em duas partes</a:t>
             </a:r>
           </a:p>
         </p:txBody>
@@ -6530,7 +6514,7 @@
                 </a:solidFill>
                 <a:latin typeface="Calibri"/>
               </a:rPr>
-              <a:t>•  Pesquisa aplicada/tecnológica: desenvolvimento de artefato + estudo de caso com aplicação piloto.</a:t>
+              <a:t>•  Pesquisa aplicada/tecnológica: desenvolvimento de artefato + estudo de caso em organização do setor elétrico (anonimizada).</a:t>
             </a:r>
           </a:p>
           <a:p>
@@ -6546,7 +6530,7 @@
                 </a:solidFill>
                 <a:latin typeface="Calibri"/>
               </a:rPr>
-              <a:t>•  Três decisões de arquitetura: custo zero · sem instalação · anonimato por construção (LGPD) — sem nome, sem dados que identifiquem pessoas ou a organização estudada.</a:t>
+              <a:t>•  Parte documental: ocorrências históricas anonimizadas reinvestigadas com o roteiro de 3 níveis — comparação com a análise original.</a:t>
             </a:r>
           </a:p>
           <a:p>
@@ -6562,7 +6546,7 @@
                 </a:solidFill>
                 <a:latin typeface="Calibri"/>
               </a:rPr>
-              <a:t>•  Frontend: página web autocontida (abre no navegador do celular). Backend: Google Apps Script + Sheets como repositório único.</a:t>
+              <a:t>•  Parte de campo: piloto com as equipes registrando novas ocorrências e condições inseguras no local, pelo celular.</a:t>
             </a:r>
           </a:p>
           <a:p>
@@ -6578,7 +6562,7 @@
                 </a:solidFill>
                 <a:latin typeface="Calibri"/>
               </a:rPr>
-              <a:t>•  Instrumento: 10 afirmativas positivas, escala Likert 1–5; média por dimensão classificada em três faixas (baixo ≥ 3,8 · médio 2,8–3,8 · alto &lt; 2,8).</a:t>
+              <a:t>•  Arquitetura: custo zero · sem instalação · página web autocontida + backend gratuito em nuvem; dados tratados de forma agregada (LGPD).</a:t>
             </a:r>
           </a:p>
         </p:txBody>
@@ -6687,7 +6671,7 @@
                 </a:solidFill>
                 <a:latin typeface="Consolas"/>
               </a:rPr>
-              <a:t>A PLATAFORMA</a:t>
+              <a:t>O SISTEMA</a:t>
             </a:r>
           </a:p>
           <a:p>
@@ -6703,7 +6687,7 @@
                 </a:solidFill>
                 <a:latin typeface="Georgia"/>
               </a:rPr>
-              <a:t>Uma base de dados, quatro módulos de SST</a:t>
+              <a:t>Módulo central + três módulos integrados</a:t>
             </a:r>
           </a:p>
         </p:txBody>
@@ -6802,7 +6786,7 @@
                 </a:solidFill>
                 <a:latin typeface="Consolas"/>
               </a:rPr>
-              <a:t>MÓDULO 1</a:t>
+              <a:t>CENTRAL</a:t>
             </a:r>
           </a:p>
           <a:p>
@@ -6812,13 +6796,13 @@
               </a:spcAft>
             </a:pPr>
             <a:r>
-              <a:rPr sz="1800" b="1">
+              <a:rPr sz="1700" b="1">
                 <a:solidFill>
                   <a:srgbClr val="16233F"/>
                 </a:solidFill>
                 <a:latin typeface="Georgia"/>
               </a:rPr>
-              <a:t>Riscos psicossociais</a:t>
+              <a:t>Acidentes e quase acidentes</a:t>
             </a:r>
           </a:p>
           <a:p>
@@ -6828,13 +6812,13 @@
               </a:spcAft>
             </a:pPr>
             <a:r>
-              <a:rPr sz="1300" b="0">
+              <a:rPr sz="1200" b="0">
                 <a:solidFill>
                   <a:srgbClr val="5B6576"/>
                 </a:solidFill>
                 <a:latin typeface="Calibri"/>
               </a:rPr>
-              <a:t>NR-1 · ISO 45003</a:t>
+              <a:t>NR-1 · NBR 14280 · árvore de causas</a:t>
             </a:r>
           </a:p>
         </p:txBody>
@@ -6943,13 +6927,13 @@
               </a:spcAft>
             </a:pPr>
             <a:r>
-              <a:rPr sz="1800" b="1">
+              <a:rPr sz="1700" b="1">
                 <a:solidFill>
                   <a:srgbClr val="16233F"/>
                 </a:solidFill>
                 <a:latin typeface="Georgia"/>
               </a:rPr>
-              <a:t>APR / PT digital</a:t>
+              <a:t>Permissão de trabalho</a:t>
             </a:r>
           </a:p>
           <a:p>
@@ -6959,7 +6943,7 @@
               </a:spcAft>
             </a:pPr>
             <a:r>
-              <a:rPr sz="1300" b="0">
+              <a:rPr sz="1200" b="0">
                 <a:solidFill>
                   <a:srgbClr val="5B6576"/>
                 </a:solidFill>
@@ -7074,13 +7058,13 @@
               </a:spcAft>
             </a:pPr>
             <a:r>
-              <a:rPr sz="1800" b="1">
+              <a:rPr sz="1700" b="1">
                 <a:solidFill>
                   <a:srgbClr val="16233F"/>
                 </a:solidFill>
                 <a:latin typeface="Georgia"/>
               </a:rPr>
-              <a:t>Ergonomia (AEP)</a:t>
+              <a:t>Riscos psicossociais</a:t>
             </a:r>
           </a:p>
           <a:p>
@@ -7090,13 +7074,13 @@
               </a:spcAft>
             </a:pPr>
             <a:r>
-              <a:rPr sz="1300" b="0">
+              <a:rPr sz="1200" b="0">
                 <a:solidFill>
                   <a:srgbClr val="5B6576"/>
                 </a:solidFill>
                 <a:latin typeface="Calibri"/>
               </a:rPr>
-              <a:t>NR-17</a:t>
+              <a:t>NR-1 · fatores humanos</a:t>
             </a:r>
           </a:p>
         </p:txBody>
@@ -7205,13 +7189,13 @@
               </a:spcAft>
             </a:pPr>
             <a:r>
-              <a:rPr sz="1800" b="1">
+              <a:rPr sz="1700" b="1">
                 <a:solidFill>
                   <a:srgbClr val="16233F"/>
                 </a:solidFill>
                 <a:latin typeface="Georgia"/>
               </a:rPr>
-              <a:t>Acidentes e near-miss</a:t>
+              <a:t>Ergonomia (AEP)</a:t>
             </a:r>
           </a:p>
           <a:p>
@@ -7221,13 +7205,13 @@
               </a:spcAft>
             </a:pPr>
             <a:r>
-              <a:rPr sz="1300" b="0">
+              <a:rPr sz="1200" b="0">
                 <a:solidFill>
                   <a:srgbClr val="5B6576"/>
                 </a:solidFill>
                 <a:latin typeface="Calibri"/>
               </a:rPr>
-              <a:t>NR-1 · árvore de causas</a:t>
+              <a:t>NR-17</a:t>
             </a:r>
           </a:p>
         </p:txBody>
@@ -7336,7 +7320,7 @@
                 </a:solidFill>
                 <a:latin typeface="Consolas"/>
               </a:rPr>
-              <a:t>MÓDULO 1 EM DETALHE</a:t>
+              <a:t>O MÓDULO CENTRAL EM DETALHE</a:t>
             </a:r>
           </a:p>
           <a:p>
@@ -7352,14 +7336,14 @@
                 </a:solidFill>
                 <a:latin typeface="Georgia"/>
               </a:rPr>
-              <a:t>Da resposta anônima ao texto do IRO — sem tabulação manual</a:t>
+              <a:t>Registro no local → 3 níveis de causas → ações e indicadores</a:t>
             </a:r>
           </a:p>
         </p:txBody>
       </p:sp>
       <p:pic>
         <p:nvPicPr>
-          <p:cNvPr id="4" name="Picture 3" descr="shot_form.png"/>
+          <p:cNvPr id="4" name="Picture 3" descr="shot_acidentes.png"/>
           <p:cNvPicPr>
             <a:picLocks noChangeAspect="1"/>
           </p:cNvPicPr>
@@ -7374,7 +7358,7 @@
         <p:spPr>
           <a:xfrm>
             <a:off x="640080" y="1737360"/>
-            <a:ext cx="5486400" cy="4343400"/>
+            <a:ext cx="5486400" cy="6771132"/>
           </a:xfrm>
           <a:prstGeom prst="rect">
             <a:avLst/>
@@ -7386,35 +7370,125 @@
           </a:ln>
         </p:spPr>
       </p:pic>
-      <p:pic>
-        <p:nvPicPr>
-          <p:cNvPr id="5" name="Picture 4" descr="shot_sobre.png"/>
-          <p:cNvPicPr>
-            <a:picLocks noChangeAspect="1"/>
-          </p:cNvPicPr>
+      <p:sp>
+        <p:nvSpPr>
+          <p:cNvPr id="5" name="TextBox 4"/>
+          <p:cNvSpPr txBox="1"/>
           <p:nvPr/>
-        </p:nvPicPr>
-        <p:blipFill>
-          <a:blip r:embed="rId3"/>
-          <a:stretch>
-            <a:fillRect/>
-          </a:stretch>
-        </p:blipFill>
+        </p:nvSpPr>
         <p:spPr>
           <a:xfrm>
-            <a:off x="6309360" y="1737360"/>
-            <a:ext cx="5303520" cy="4198620"/>
+            <a:off x="6492240" y="1737360"/>
+            <a:ext cx="5120640" cy="4206240"/>
           </a:xfrm>
           <a:prstGeom prst="rect">
             <a:avLst/>
           </a:prstGeom>
-          <a:ln w="12700">
-            <a:solidFill>
-              <a:srgbClr val="DDE2E9"/>
-            </a:solidFill>
-          </a:ln>
+          <a:noFill/>
         </p:spPr>
-      </p:pic>
+        <p:txBody>
+          <a:bodyPr wrap="square">
+            <a:spAutoFit/>
+          </a:bodyPr>
+          <a:lstStyle/>
+          <a:p>
+            <a:pPr algn="l">
+              <a:spcAft>
+                <a:spcPts val="800"/>
+              </a:spcAft>
+            </a:pPr>
+            <a:r>
+              <a:rPr sz="1600" b="1">
+                <a:solidFill>
+                  <a:srgbClr val="16233F"/>
+                </a:solidFill>
+                <a:latin typeface="Georgia"/>
+              </a:rPr>
+              <a:t>Fluxo da investigação</a:t>
+            </a:r>
+          </a:p>
+          <a:p>
+            <a:pPr algn="l">
+              <a:spcAft>
+                <a:spcPts val="600"/>
+              </a:spcAft>
+            </a:pPr>
+            <a:r>
+              <a:rPr sz="1300" b="0">
+                <a:solidFill>
+                  <a:srgbClr val="5B6576"/>
+                </a:solidFill>
+                <a:latin typeface="Calibri"/>
+              </a:rPr>
+              <a:t>1. Registro em &lt; 5 min: tipo, tarefa, descrição — alerta de CAT automático quando aplicável.</a:t>
+            </a:r>
+          </a:p>
+          <a:p>
+            <a:pPr algn="l">
+              <a:spcAft>
+                <a:spcPts val="600"/>
+              </a:spcAft>
+            </a:pPr>
+            <a:r>
+              <a:rPr sz="1300" b="0">
+                <a:solidFill>
+                  <a:srgbClr val="5B6576"/>
+                </a:solidFill>
+                <a:latin typeface="Calibri"/>
+              </a:rPr>
+              <a:t>2. Causas imediatas: o que produziu o dano na cena.</a:t>
+            </a:r>
+          </a:p>
+          <a:p>
+            <a:pPr algn="l">
+              <a:spcAft>
+                <a:spcPts val="600"/>
+              </a:spcAft>
+            </a:pPr>
+            <a:r>
+              <a:rPr sz="1300" b="0">
+                <a:solidFill>
+                  <a:srgbClr val="5B6576"/>
+                </a:solidFill>
+                <a:latin typeface="Calibri"/>
+              </a:rPr>
+              <a:t>3. Causas subjacentes: o que na tarefa/posto tornou possível.</a:t>
+            </a:r>
+          </a:p>
+          <a:p>
+            <a:pPr algn="l">
+              <a:spcAft>
+                <a:spcPts val="600"/>
+              </a:spcAft>
+            </a:pPr>
+            <a:r>
+              <a:rPr sz="1300" b="0">
+                <a:solidFill>
+                  <a:srgbClr val="5B6576"/>
+                </a:solidFill>
+                <a:latin typeface="Calibri"/>
+              </a:rPr>
+              <a:t>4. Causas básicas: o que na gestão/organização originou — inclui fatores humanos (fadiga, sobrecarga).</a:t>
+            </a:r>
+          </a:p>
+          <a:p>
+            <a:pPr algn="l">
+              <a:spcAft>
+                <a:spcPts val="600"/>
+              </a:spcAft>
+            </a:pPr>
+            <a:r>
+              <a:rPr sz="1300" b="0">
+                <a:solidFill>
+                  <a:srgbClr val="5B6576"/>
+                </a:solidFill>
+                <a:latin typeface="Calibri"/>
+              </a:rPr>
+              <a:t>5. Ações com responsável, prazo e status; indicadores automáticos (razão QA/acidentes, TF/TG da NBR 14280).</a:t>
+            </a:r>
+          </a:p>
+        </p:txBody>
+      </p:sp>
     </p:spTree>
   </p:cSld>
   <p:clrMapOvr>
@@ -7519,7 +7593,7 @@
                 </a:solidFill>
                 <a:latin typeface="Consolas"/>
               </a:rPr>
-              <a:t>MÓDULOS 2 A 4</a:t>
+              <a:t>MÓDULOS INTEGRADOS</a:t>
             </a:r>
           </a:p>
           <a:p>
@@ -7535,7 +7609,7 @@
                 </a:solidFill>
                 <a:latin typeface="Georgia"/>
               </a:rPr>
-              <a:t>Permissão de trabalho, ergonomia e acidentes</a:t>
+              <a:t>Permissão de trabalho, psicossocial e ergonomia</a:t>
             </a:r>
           </a:p>
         </p:txBody>
@@ -7571,7 +7645,7 @@
       </p:pic>
       <p:pic>
         <p:nvPicPr>
-          <p:cNvPr id="5" name="Picture 4" descr="shot_aep.png"/>
+          <p:cNvPr id="5" name="Picture 4" descr="shot_form.png"/>
           <p:cNvPicPr>
             <a:picLocks noChangeAspect="1"/>
           </p:cNvPicPr>
@@ -7600,7 +7674,7 @@
       </p:pic>
       <p:pic>
         <p:nvPicPr>
-          <p:cNvPr id="6" name="Picture 5" descr="shot_acidentes.png"/>
+          <p:cNvPr id="6" name="Picture 5" descr="shot_aep.png"/>
           <p:cNvPicPr>
             <a:picLocks noChangeAspect="1"/>
           </p:cNvPicPr>
@@ -7615,7 +7689,7 @@
         <p:spPr>
           <a:xfrm>
             <a:off x="8138160" y="1737360"/>
-            <a:ext cx="3383280" cy="4175531"/>
+            <a:ext cx="3383280" cy="2678430"/>
           </a:xfrm>
           <a:prstGeom prst="rect">
             <a:avLst/>
@@ -7661,7 +7735,7 @@
                 </a:solidFill>
                 <a:latin typeface="Calibri"/>
               </a:rPr>
-              <a:t>M2: checklist NR-10/35, geolocalização e assinatura digital  ·  M3: AEP em 5 blocos com parecer  ·  M4: árvore de causas e CAT</a:t>
+              <a:t>PT: checklist NR-10/35, geolocalização e assinatura  ·  Psicossocial: 10 itens anônimos, 6 dimensões  ·  AEP: 5 blocos com parecer</a:t>
             </a:r>
           </a:p>
         </p:txBody>

</xml_diff>